<commit_message>
Label the Consolidation step as TRANSFORM (Python) on the diagram
</commit_message>
<xml_diff>
--- a/diagram/pipeline-elt-bloc3.pptx
+++ b/diagram/pipeline-elt-bloc3.pptx
@@ -7374,6 +7374,41 @@
                 <a:latin typeface="Segoe UI"/>
               </a:rPr>
               <a:t>AutoMeca Systems</a:t>
+            </a:r>
+          </a:p>
+        </p:txBody>
+      </p:sp>
+      <p:sp>
+        <p:nvSpPr>
+          <p:cNvPr id="113" name="TextBox Consolidation Transform"/>
+          <p:cNvSpPr txBox="1"/>
+          <p:nvPr/>
+        </p:nvSpPr>
+        <p:spPr>
+          <a:xfrm>
+            <a:off x="7562088" y="4782312"/>
+            <a:ext cx="1691640" cy="164592"/>
+          </a:xfrm>
+          <a:prstGeom prst="rect">
+            <a:avLst/>
+          </a:prstGeom>
+          <a:noFill/>
+        </p:spPr>
+        <p:txBody>
+          <a:bodyPr wrap="square" lIns="0" rIns="0" tIns="0" bIns="0">
+            <a:spAutoFit/>
+          </a:bodyPr>
+          <a:lstStyle/>
+          <a:p>
+            <a:pPr algn="ctr"/>
+            <a:r>
+              <a:rPr sz="660" b="1" i="0">
+                <a:solidFill>
+                  <a:srgbClr val="3776AB"/>
+                </a:solidFill>
+                <a:latin typeface="Segoe UI"/>
+              </a:rPr>
+              <a:t>TRANSFORM (Python)</a:t>
             </a:r>
           </a:p>
         </p:txBody>

</xml_diff>

<commit_message>
Clarify per-message vs periodic control distinction on the diagram
</commit_message>
<xml_diff>
--- a/diagram/pipeline-elt-bloc3.pptx
+++ b/diagram/pipeline-elt-bloc3.pptx
@@ -8694,10 +8694,10 @@
                 </a:solidFill>
                 <a:latin typeface="Segoe UI"/>
               </a:rPr>
-              <a:t>Contrôles automatiques appliqués à chaque mesure :
-•  Valeur hors plage (aberrante)
-•  Capteur silencieux (donnée manquante)
-Une donnée suspecte est isolée en quarantaine — elle n'est jamais fusionnée avec les données validées.</a:t>
+              <a:t>Contrôles automatiques :
+•  Valeur hors plage (aberrante) — par mesure, quarantaine si suspecte
+•  Capteur silencieux (donnée manquante) — contrôle périodique, alerte
+Une valeur hors plage est isolée en quarantaine — jamais fusionnée avec les données validées.</a:t>
             </a:r>
           </a:p>
         </p:txBody>

</xml_diff>